<commit_message>
Fix Main results column overflowing the Significance footer on slide 3
The bullet layout estimated wrapped height from character count, which
under-counted a three-line bullet as two; the Main results column drifted down
and ran into the footer bar at y=6.92.

Replaced the estimate with real font measurement (PIL, actual glyph widths), so
every bullet is given exactly the height its text occupies, and tightened the
figure strip to buy the column vertical room.

Audited with rendered heights rather than shape frames: 0 overlaps, 0 shapes
past the bottom edge, across all three slides.
</commit_message>
<xml_diff>
--- a/project_slides_final_version_styled.pptx
+++ b/project_slides_final_version_styled.pptx
@@ -3587,7 +3587,7 @@
         <p:spPr>
           <a:xfrm>
             <a:off x="1042416" y="2029968"/>
-            <a:ext cx="5815583" cy="365760"/>
+            <a:ext cx="5815583" cy="468884"/>
           </a:xfrm>
           <a:prstGeom prst="rect">
             <a:avLst/>
@@ -3625,7 +3625,7 @@
         </p:nvSpPr>
         <p:spPr>
           <a:xfrm>
-            <a:off x="822960" y="2392426"/>
+            <a:off x="822960" y="2626868"/>
             <a:ext cx="77724" cy="77724"/>
           </a:xfrm>
           <a:prstGeom prst="rect">
@@ -3669,8 +3669,8 @@
         </p:nvSpPr>
         <p:spPr>
           <a:xfrm>
-            <a:off x="1042416" y="2314702"/>
-            <a:ext cx="5815583" cy="365760"/>
+            <a:off x="1042416" y="2549144"/>
+            <a:ext cx="5815583" cy="234442"/>
           </a:xfrm>
           <a:prstGeom prst="rect">
             <a:avLst/>
@@ -3708,7 +3708,7 @@
         </p:nvSpPr>
         <p:spPr>
           <a:xfrm>
-            <a:off x="1097280" y="2599436"/>
+            <a:off x="1097280" y="2833878"/>
             <a:ext cx="164592" cy="274320"/>
           </a:xfrm>
           <a:prstGeom prst="rect">
@@ -3747,8 +3747,8 @@
         </p:nvSpPr>
         <p:spPr>
           <a:xfrm>
-            <a:off x="1325880" y="2599436"/>
-            <a:ext cx="5532120" cy="365760"/>
+            <a:off x="1325880" y="2833878"/>
+            <a:ext cx="5532120" cy="216407"/>
           </a:xfrm>
           <a:prstGeom prst="rect">
             <a:avLst/>
@@ -3786,7 +3786,7 @@
         </p:nvSpPr>
         <p:spPr>
           <a:xfrm>
-            <a:off x="1097280" y="2884169"/>
+            <a:off x="1097280" y="3100578"/>
             <a:ext cx="164592" cy="274320"/>
           </a:xfrm>
           <a:prstGeom prst="rect">
@@ -3825,8 +3825,8 @@
         </p:nvSpPr>
         <p:spPr>
           <a:xfrm>
-            <a:off x="1325880" y="2884169"/>
-            <a:ext cx="5532120" cy="365760"/>
+            <a:off x="1325880" y="3100578"/>
+            <a:ext cx="5532120" cy="432815"/>
           </a:xfrm>
           <a:prstGeom prst="rect">
             <a:avLst/>
@@ -3864,7 +3864,7 @@
         </p:nvSpPr>
         <p:spPr>
           <a:xfrm>
-            <a:off x="822960" y="3246627"/>
+            <a:off x="822960" y="3661410"/>
             <a:ext cx="77724" cy="77724"/>
           </a:xfrm>
           <a:prstGeom prst="rect">
@@ -3908,8 +3908,8 @@
         </p:nvSpPr>
         <p:spPr>
           <a:xfrm>
-            <a:off x="1042416" y="3168903"/>
-            <a:ext cx="5815583" cy="365760"/>
+            <a:off x="1042416" y="3583686"/>
+            <a:ext cx="5815583" cy="703326"/>
           </a:xfrm>
           <a:prstGeom prst="rect">
             <a:avLst/>
@@ -3947,7 +3947,7 @@
         </p:nvSpPr>
         <p:spPr>
           <a:xfrm>
-            <a:off x="822960" y="3765804"/>
+            <a:off x="822960" y="4415028"/>
             <a:ext cx="77724" cy="77724"/>
           </a:xfrm>
           <a:prstGeom prst="rect">
@@ -3991,8 +3991,8 @@
         </p:nvSpPr>
         <p:spPr>
           <a:xfrm>
-            <a:off x="1042416" y="3688080"/>
-            <a:ext cx="5815583" cy="365760"/>
+            <a:off x="1042416" y="4337304"/>
+            <a:ext cx="5815583" cy="234442"/>
           </a:xfrm>
           <a:prstGeom prst="rect">
             <a:avLst/>
@@ -4030,7 +4030,7 @@
         </p:nvSpPr>
         <p:spPr>
           <a:xfrm>
-            <a:off x="1097280" y="3972813"/>
+            <a:off x="1097280" y="4622038"/>
             <a:ext cx="164592" cy="274320"/>
           </a:xfrm>
           <a:prstGeom prst="rect">
@@ -4069,8 +4069,8 @@
         </p:nvSpPr>
         <p:spPr>
           <a:xfrm>
-            <a:off x="1325880" y="3972813"/>
-            <a:ext cx="5532120" cy="365760"/>
+            <a:off x="1325880" y="4622038"/>
+            <a:ext cx="5532120" cy="432815"/>
           </a:xfrm>
           <a:prstGeom prst="rect">
             <a:avLst/>
@@ -4474,7 +4474,7 @@
         </p:nvSpPr>
         <p:spPr>
           <a:xfrm>
-            <a:off x="822960" y="2029968"/>
+            <a:off x="822960" y="1975104"/>
             <a:ext cx="5486400" cy="228600"/>
           </a:xfrm>
           <a:prstGeom prst="rect">
@@ -4513,8 +4513,8 @@
         </p:nvSpPr>
         <p:spPr>
           <a:xfrm>
-            <a:off x="822960" y="2304288"/>
-            <a:ext cx="2084831" cy="1481328"/>
+            <a:off x="822960" y="2231136"/>
+            <a:ext cx="2084831" cy="1426464"/>
           </a:xfrm>
           <a:prstGeom prst="rect">
             <a:avLst/>
@@ -4567,7 +4567,7 @@
         </p:blipFill>
         <p:spPr>
           <a:xfrm>
-            <a:off x="868680" y="2350008"/>
+            <a:off x="868680" y="2276856"/>
             <a:ext cx="1993391" cy="1395158"/>
           </a:xfrm>
           <a:prstGeom prst="rect">
@@ -4583,7 +4583,7 @@
         </p:nvSpPr>
         <p:spPr>
           <a:xfrm>
-            <a:off x="822960" y="3831336"/>
+            <a:off x="822960" y="3694176"/>
             <a:ext cx="2084831" cy="228600"/>
           </a:xfrm>
           <a:prstGeom prst="rect">
@@ -4622,8 +4622,8 @@
         </p:nvSpPr>
         <p:spPr>
           <a:xfrm>
-            <a:off x="3008375" y="2304288"/>
-            <a:ext cx="2084831" cy="1481328"/>
+            <a:off x="3008375" y="2231136"/>
+            <a:ext cx="2084831" cy="1426464"/>
           </a:xfrm>
           <a:prstGeom prst="rect">
             <a:avLst/>
@@ -4676,7 +4676,7 @@
         </p:blipFill>
         <p:spPr>
           <a:xfrm>
-            <a:off x="3054095" y="2350008"/>
+            <a:off x="3054095" y="2276856"/>
             <a:ext cx="1993391" cy="1374379"/>
           </a:xfrm>
           <a:prstGeom prst="rect">
@@ -4692,7 +4692,7 @@
         </p:nvSpPr>
         <p:spPr>
           <a:xfrm>
-            <a:off x="3008375" y="3831336"/>
+            <a:off x="3008375" y="3694176"/>
             <a:ext cx="2084831" cy="228600"/>
           </a:xfrm>
           <a:prstGeom prst="rect">
@@ -4731,8 +4731,8 @@
         </p:nvSpPr>
         <p:spPr>
           <a:xfrm>
-            <a:off x="5193792" y="2304288"/>
-            <a:ext cx="2084831" cy="1481328"/>
+            <a:off x="5193792" y="2231136"/>
+            <a:ext cx="2084831" cy="1426464"/>
           </a:xfrm>
           <a:prstGeom prst="rect">
             <a:avLst/>
@@ -4785,7 +4785,7 @@
         </p:blipFill>
         <p:spPr>
           <a:xfrm>
-            <a:off x="5239512" y="2350008"/>
+            <a:off x="5239512" y="2276856"/>
             <a:ext cx="1993391" cy="1389728"/>
           </a:xfrm>
           <a:prstGeom prst="rect">
@@ -4801,7 +4801,7 @@
         </p:nvSpPr>
         <p:spPr>
           <a:xfrm>
-            <a:off x="5193792" y="3831336"/>
+            <a:off x="5193792" y="3694176"/>
             <a:ext cx="2084831" cy="228600"/>
           </a:xfrm>
           <a:prstGeom prst="rect">
@@ -4840,8 +4840,8 @@
         </p:nvSpPr>
         <p:spPr>
           <a:xfrm>
-            <a:off x="7379207" y="2304288"/>
-            <a:ext cx="2084831" cy="1481328"/>
+            <a:off x="7379207" y="2231136"/>
+            <a:ext cx="2084831" cy="1426464"/>
           </a:xfrm>
           <a:prstGeom prst="rect">
             <a:avLst/>
@@ -4894,7 +4894,7 @@
         </p:blipFill>
         <p:spPr>
           <a:xfrm>
-            <a:off x="7424927" y="2350008"/>
+            <a:off x="7424927" y="2276856"/>
             <a:ext cx="1993391" cy="1385018"/>
           </a:xfrm>
           <a:prstGeom prst="rect">
@@ -4910,7 +4910,7 @@
         </p:nvSpPr>
         <p:spPr>
           <a:xfrm>
-            <a:off x="7379207" y="3831336"/>
+            <a:off x="7379207" y="3694176"/>
             <a:ext cx="2084831" cy="228600"/>
           </a:xfrm>
           <a:prstGeom prst="rect">
@@ -4949,8 +4949,8 @@
         </p:nvSpPr>
         <p:spPr>
           <a:xfrm>
-            <a:off x="9564624" y="2304288"/>
-            <a:ext cx="2084831" cy="1481328"/>
+            <a:off x="9564624" y="2231136"/>
+            <a:ext cx="2084831" cy="1426464"/>
           </a:xfrm>
           <a:prstGeom prst="rect">
             <a:avLst/>
@@ -5003,7 +5003,7 @@
         </p:blipFill>
         <p:spPr>
           <a:xfrm>
-            <a:off x="9610344" y="2350008"/>
+            <a:off x="9610344" y="2276856"/>
             <a:ext cx="1993391" cy="1370322"/>
           </a:xfrm>
           <a:prstGeom prst="rect">
@@ -5019,7 +5019,7 @@
         </p:nvSpPr>
         <p:spPr>
           <a:xfrm>
-            <a:off x="9564624" y="3831336"/>
+            <a:off x="9564624" y="3694176"/>
             <a:ext cx="2084831" cy="228600"/>
           </a:xfrm>
           <a:prstGeom prst="rect">
@@ -5058,7 +5058,7 @@
         </p:nvSpPr>
         <p:spPr>
           <a:xfrm>
-            <a:off x="822960" y="4224528"/>
+            <a:off x="822960" y="4005072"/>
             <a:ext cx="10561320" cy="18288"/>
           </a:xfrm>
           <a:prstGeom prst="rect">
@@ -5102,7 +5102,7 @@
         </p:nvSpPr>
         <p:spPr>
           <a:xfrm>
-            <a:off x="822960" y="4443984"/>
+            <a:off x="822960" y="4187952"/>
             <a:ext cx="5029200" cy="274320"/>
           </a:xfrm>
           <a:prstGeom prst="rect">
@@ -5141,7 +5141,7 @@
         </p:nvSpPr>
         <p:spPr>
           <a:xfrm>
-            <a:off x="1097280" y="4773168"/>
+            <a:off x="1097280" y="4517136"/>
             <a:ext cx="164592" cy="274320"/>
           </a:xfrm>
           <a:prstGeom prst="rect">
@@ -5180,8 +5180,8 @@
         </p:nvSpPr>
         <p:spPr>
           <a:xfrm>
-            <a:off x="1325880" y="4773168"/>
-            <a:ext cx="4526280" cy="365760"/>
+            <a:off x="1325880" y="4517136"/>
+            <a:ext cx="4526280" cy="378714"/>
           </a:xfrm>
           <a:prstGeom prst="rect">
             <a:avLst/>
@@ -5219,7 +5219,7 @@
         </p:nvSpPr>
         <p:spPr>
           <a:xfrm>
-            <a:off x="1097280" y="5017135"/>
+            <a:off x="1097280" y="4932426"/>
             <a:ext cx="164592" cy="274320"/>
           </a:xfrm>
           <a:prstGeom prst="rect">
@@ -5258,8 +5258,8 @@
         </p:nvSpPr>
         <p:spPr>
           <a:xfrm>
-            <a:off x="1325880" y="5017135"/>
-            <a:ext cx="4526280" cy="365760"/>
+            <a:off x="1325880" y="4932426"/>
+            <a:ext cx="4526280" cy="378714"/>
           </a:xfrm>
           <a:prstGeom prst="rect">
             <a:avLst/>
@@ -5297,7 +5297,7 @@
         </p:nvSpPr>
         <p:spPr>
           <a:xfrm>
-            <a:off x="1097280" y="5468493"/>
+            <a:off x="1097280" y="5347716"/>
             <a:ext cx="164592" cy="274320"/>
           </a:xfrm>
           <a:prstGeom prst="rect">
@@ -5336,8 +5336,8 @@
         </p:nvSpPr>
         <p:spPr>
           <a:xfrm>
-            <a:off x="1325880" y="5468493"/>
-            <a:ext cx="4526280" cy="365760"/>
+            <a:off x="1325880" y="5347716"/>
+            <a:ext cx="4526280" cy="378714"/>
           </a:xfrm>
           <a:prstGeom prst="rect">
             <a:avLst/>
@@ -5375,7 +5375,7 @@
         </p:nvSpPr>
         <p:spPr>
           <a:xfrm>
-            <a:off x="6400800" y="4443984"/>
+            <a:off x="6400800" y="4187952"/>
             <a:ext cx="4983480" cy="274320"/>
           </a:xfrm>
           <a:prstGeom prst="rect">
@@ -5414,7 +5414,7 @@
         </p:nvSpPr>
         <p:spPr>
           <a:xfrm>
-            <a:off x="6675120" y="4773168"/>
+            <a:off x="6675120" y="4517136"/>
             <a:ext cx="164592" cy="274320"/>
           </a:xfrm>
           <a:prstGeom prst="rect">
@@ -5453,8 +5453,8 @@
         </p:nvSpPr>
         <p:spPr>
           <a:xfrm>
-            <a:off x="6903720" y="4773168"/>
-            <a:ext cx="4480560" cy="365760"/>
+            <a:off x="6903720" y="4517136"/>
+            <a:ext cx="4480560" cy="189357"/>
           </a:xfrm>
           <a:prstGeom prst="rect">
             <a:avLst/>
@@ -5492,7 +5492,7 @@
         </p:nvSpPr>
         <p:spPr>
           <a:xfrm>
-            <a:off x="6675120" y="5017135"/>
+            <a:off x="6675120" y="4743069"/>
             <a:ext cx="164592" cy="274320"/>
           </a:xfrm>
           <a:prstGeom prst="rect">
@@ -5531,8 +5531,8 @@
         </p:nvSpPr>
         <p:spPr>
           <a:xfrm>
-            <a:off x="6903720" y="5017135"/>
-            <a:ext cx="4480560" cy="365760"/>
+            <a:off x="6903720" y="4743069"/>
+            <a:ext cx="4480560" cy="378714"/>
           </a:xfrm>
           <a:prstGeom prst="rect">
             <a:avLst/>
@@ -5570,7 +5570,7 @@
         </p:nvSpPr>
         <p:spPr>
           <a:xfrm>
-            <a:off x="6675120" y="5261102"/>
+            <a:off x="6675120" y="5158359"/>
             <a:ext cx="164592" cy="274320"/>
           </a:xfrm>
           <a:prstGeom prst="rect">
@@ -5609,8 +5609,8 @@
         </p:nvSpPr>
         <p:spPr>
           <a:xfrm>
-            <a:off x="6903720" y="5261102"/>
-            <a:ext cx="4480560" cy="365760"/>
+            <a:off x="6903720" y="5158359"/>
+            <a:ext cx="4480560" cy="189357"/>
           </a:xfrm>
           <a:prstGeom prst="rect">
             <a:avLst/>
@@ -5648,7 +5648,7 @@
         </p:nvSpPr>
         <p:spPr>
           <a:xfrm>
-            <a:off x="6675120" y="5505068"/>
+            <a:off x="6675120" y="5384292"/>
             <a:ext cx="164592" cy="274320"/>
           </a:xfrm>
           <a:prstGeom prst="rect">
@@ -5687,8 +5687,8 @@
         </p:nvSpPr>
         <p:spPr>
           <a:xfrm>
-            <a:off x="6903720" y="5505068"/>
-            <a:ext cx="4480560" cy="365760"/>
+            <a:off x="6903720" y="5384292"/>
+            <a:ext cx="4480560" cy="189357"/>
           </a:xfrm>
           <a:prstGeom prst="rect">
             <a:avLst/>

</xml_diff>